<commit_message>
Point the deck at the airuntime-max repository
</commit_message>
<xml_diff>
--- a/docs/max-presentation/presentation.pptx
+++ b/docs/max-presentation/presentation.pptx
@@ -3188,7 +3188,7 @@
                 <a:ea typeface="Consolas" pitchFamily="34" charset="-122"/>
                 <a:cs typeface="Consolas" pitchFamily="34" charset="-120"/>
               </a:rPr>
-              <a:t>github.com/airuntime-ru/airuntime</a:t>
+              <a:t>github.com/airuntime-ru/airuntime-max</a:t>
             </a:r>
             <a:endParaRPr lang="en-US" sz="1150" dirty="0"/>
           </a:p>
@@ -19986,7 +19986,7 @@
                 <a:ea typeface="Calibri" pitchFamily="34" charset="-122"/>
                 <a:cs typeface="Calibri" pitchFamily="34" charset="-120"/>
               </a:rPr>
-              <a:t>github.com/airuntime-ru/airuntime</a:t>
+              <a:t>github.com/airuntime-ru/airuntime-max</a:t>
             </a:r>
             <a:endParaRPr lang="en-US" sz="1300" dirty="0"/>
           </a:p>

</xml_diff>